<commit_message>
feat(deck): add prominent GitHub repository callout box and footer link to last slide
- Added dedicated callout card with clickable hyperlink to https://github.com/joshuadjd79-cmd/resilient-compiler-intelligent-error-recovery on Slide 18
- Added persistent repository footer link across Slide 18
- Updated PPTX Slide 18 text to include the official GitHub repository link
- Recompiled Resilient_Compiler_Phase3_Presentation.pdf and .pptx in root and docs/
</commit_message>
<xml_diff>
--- a/Resilient_Compiler_Phase3_Presentation.pptx
+++ b/Resilient_Compiler_Phase3_Presentation.pptx
@@ -4995,6 +4995,15 @@
             </a:pPr>
             <a:r>
               <a:t>Complete deliverables: resilientc.exe, academic report, complete explanation, web studio, 20/20 test suite.</a:t>
+            </a:r>
+            <a:br/>
+            <a:br/>
+            <a:r>
+              <a:t>Official GitHub Repository:</a:t>
+            </a:r>
+            <a:br/>
+            <a:r>
+              <a:t>https://github.com/joshuadjd79-cmd/resilient-compiler-intelligent-error-recovery</a:t>
             </a:r>
           </a:p>
         </p:txBody>

</xml_diff>